<commit_message>
Update Student Engagement Intelligence and Retention Portfolio.pptx
</commit_message>
<xml_diff>
--- a/Student Engagement Intelligence and Retention Portfolio.pptx
+++ b/Student Engagement Intelligence and Retention Portfolio.pptx
@@ -201,7 +201,7 @@
           <a:p>
             <a:fld id="{A109B386-FF78-8641-A5E7-74BA71E944AA}" type="datetimeFigureOut">
               <a:rPr lang="en-US" smtClean="0"/>
-              <a:t>4/20/26</a:t>
+              <a:t>4/21/26</a:t>
             </a:fld>
             <a:endParaRPr lang="en-US"/>
           </a:p>
@@ -1027,7 +1027,7 @@
           <a:p>
             <a:fld id="{D0F8A4A8-4142-0648-99A9-95D3C2C8FC12}" type="datetimeFigureOut">
               <a:rPr lang="en-US" smtClean="0"/>
-              <a:t>4/20/26</a:t>
+              <a:t>4/21/26</a:t>
             </a:fld>
             <a:endParaRPr lang="en-US"/>
           </a:p>
@@ -1225,7 +1225,7 @@
           <a:p>
             <a:fld id="{D0F8A4A8-4142-0648-99A9-95D3C2C8FC12}" type="datetimeFigureOut">
               <a:rPr lang="en-US" smtClean="0"/>
-              <a:t>4/20/26</a:t>
+              <a:t>4/21/26</a:t>
             </a:fld>
             <a:endParaRPr lang="en-US"/>
           </a:p>
@@ -1433,7 +1433,7 @@
           <a:p>
             <a:fld id="{D0F8A4A8-4142-0648-99A9-95D3C2C8FC12}" type="datetimeFigureOut">
               <a:rPr lang="en-US" smtClean="0"/>
-              <a:t>4/20/26</a:t>
+              <a:t>4/21/26</a:t>
             </a:fld>
             <a:endParaRPr lang="en-US"/>
           </a:p>
@@ -1631,7 +1631,7 @@
           <a:p>
             <a:fld id="{D0F8A4A8-4142-0648-99A9-95D3C2C8FC12}" type="datetimeFigureOut">
               <a:rPr lang="en-US" smtClean="0"/>
-              <a:t>4/20/26</a:t>
+              <a:t>4/21/26</a:t>
             </a:fld>
             <a:endParaRPr lang="en-US"/>
           </a:p>
@@ -1906,7 +1906,7 @@
           <a:p>
             <a:fld id="{D0F8A4A8-4142-0648-99A9-95D3C2C8FC12}" type="datetimeFigureOut">
               <a:rPr lang="en-US" smtClean="0"/>
-              <a:t>4/20/26</a:t>
+              <a:t>4/21/26</a:t>
             </a:fld>
             <a:endParaRPr lang="en-US"/>
           </a:p>
@@ -2171,7 +2171,7 @@
           <a:p>
             <a:fld id="{D0F8A4A8-4142-0648-99A9-95D3C2C8FC12}" type="datetimeFigureOut">
               <a:rPr lang="en-US" smtClean="0"/>
-              <a:t>4/20/26</a:t>
+              <a:t>4/21/26</a:t>
             </a:fld>
             <a:endParaRPr lang="en-US"/>
           </a:p>
@@ -2583,7 +2583,7 @@
           <a:p>
             <a:fld id="{D0F8A4A8-4142-0648-99A9-95D3C2C8FC12}" type="datetimeFigureOut">
               <a:rPr lang="en-US" smtClean="0"/>
-              <a:t>4/20/26</a:t>
+              <a:t>4/21/26</a:t>
             </a:fld>
             <a:endParaRPr lang="en-US"/>
           </a:p>
@@ -2724,7 +2724,7 @@
           <a:p>
             <a:fld id="{D0F8A4A8-4142-0648-99A9-95D3C2C8FC12}" type="datetimeFigureOut">
               <a:rPr lang="en-US" smtClean="0"/>
-              <a:t>4/20/26</a:t>
+              <a:t>4/21/26</a:t>
             </a:fld>
             <a:endParaRPr lang="en-US"/>
           </a:p>
@@ -2837,7 +2837,7 @@
           <a:p>
             <a:fld id="{D0F8A4A8-4142-0648-99A9-95D3C2C8FC12}" type="datetimeFigureOut">
               <a:rPr lang="en-US" smtClean="0"/>
-              <a:t>4/20/26</a:t>
+              <a:t>4/21/26</a:t>
             </a:fld>
             <a:endParaRPr lang="en-US"/>
           </a:p>
@@ -3148,7 +3148,7 @@
           <a:p>
             <a:fld id="{D0F8A4A8-4142-0648-99A9-95D3C2C8FC12}" type="datetimeFigureOut">
               <a:rPr lang="en-US" smtClean="0"/>
-              <a:t>4/20/26</a:t>
+              <a:t>4/21/26</a:t>
             </a:fld>
             <a:endParaRPr lang="en-US"/>
           </a:p>
@@ -3436,7 +3436,7 @@
           <a:p>
             <a:fld id="{D0F8A4A8-4142-0648-99A9-95D3C2C8FC12}" type="datetimeFigureOut">
               <a:rPr lang="en-US" smtClean="0"/>
-              <a:t>4/20/26</a:t>
+              <a:t>4/21/26</a:t>
             </a:fld>
             <a:endParaRPr lang="en-US"/>
           </a:p>
@@ -3677,7 +3677,7 @@
           <a:p>
             <a:fld id="{D0F8A4A8-4142-0648-99A9-95D3C2C8FC12}" type="datetimeFigureOut">
               <a:rPr lang="en-US" smtClean="0"/>
-              <a:t>4/20/26</a:t>
+              <a:t>4/21/26</a:t>
             </a:fld>
             <a:endParaRPr lang="en-US"/>
           </a:p>
@@ -4268,8 +4268,13 @@
             <a:pPr lvl="1"/>
             <a:r>
               <a:rPr lang="en-US" dirty="0"/>
-              <a:t>K-Means, KNN, SVN</a:t>
-            </a:r>
+              <a:t>K-Means, KNN</a:t>
+            </a:r>
+            <a:r>
+              <a:rPr lang="en-US"/>
+              <a:t>, SVM</a:t>
+            </a:r>
+            <a:endParaRPr lang="en-US" dirty="0"/>
           </a:p>
           <a:p>
             <a:pPr lvl="1"/>

</xml_diff>